<commit_message>
content: add UC Berkeley badge to every slide
</commit_message>
<xml_diff>
--- a/docs/Navigation-Guidance-Capstone-light.pptx
+++ b/docs/Navigation-Guidance-Capstone-light.pptx
@@ -17,6 +17,7 @@
     <p:sldId id="265" r:id="rId16"/>
     <p:sldId id="266" r:id="rId17"/>
     <p:sldId id="267" r:id="rId18"/>
+    <p:sldId id="268" r:id="rId19"/>
   </p:sldIdLst>
   <p:sldSz cx="12191695" cy="6858000" type="screen4x3"/>
   <p:notesSz cx="6858000" cy="9144000"/>
@@ -3101,7 +3102,7 @@
       <p:grpSpPr/>
       <p:pic>
         <p:nvPicPr>
-          <p:cNvPr id="2" name="Picture 1" descr="s01.jpg"/>
+          <p:cNvPr id="2" name="Picture 1" descr="image.jpg"/>
           <p:cNvPicPr>
             <a:picLocks noChangeAspect="1"/>
           </p:cNvPicPr>
@@ -3143,7 +3144,7 @@
       <p:grpSpPr/>
       <p:pic>
         <p:nvPicPr>
-          <p:cNvPr id="2" name="Picture 1" descr="s10.jpg"/>
+          <p:cNvPr id="2" name="Picture 1" descr="image.jpg"/>
           <p:cNvPicPr>
             <a:picLocks noChangeAspect="1"/>
           </p:cNvPicPr>
@@ -3185,7 +3186,7 @@
       <p:grpSpPr/>
       <p:pic>
         <p:nvPicPr>
-          <p:cNvPr id="2" name="Picture 1" descr="s11.jpg"/>
+          <p:cNvPr id="2" name="Picture 1" descr="image.jpg"/>
           <p:cNvPicPr>
             <a:picLocks noChangeAspect="1"/>
           </p:cNvPicPr>
@@ -3227,7 +3228,49 @@
       <p:grpSpPr/>
       <p:pic>
         <p:nvPicPr>
-          <p:cNvPr id="2" name="Picture 1" descr="s12.jpg"/>
+          <p:cNvPr id="2" name="Picture 1" descr="image.jpg"/>
+          <p:cNvPicPr>
+            <a:picLocks noChangeAspect="1"/>
+          </p:cNvPicPr>
+          <p:nvPr/>
+        </p:nvPicPr>
+        <p:blipFill>
+          <a:blip r:embed="rId2"/>
+          <a:stretch>
+            <a:fillRect/>
+          </a:stretch>
+        </p:blipFill>
+        <p:spPr>
+          <a:xfrm>
+            <a:off x="0" y="0"/>
+            <a:ext cx="12191695" cy="6858000"/>
+          </a:xfrm>
+          <a:prstGeom prst="rect">
+            <a:avLst/>
+          </a:prstGeom>
+        </p:spPr>
+      </p:pic>
+    </p:spTree>
+  </p:cSld>
+  <p:clrMapOvr>
+    <a:masterClrMapping/>
+  </p:clrMapOvr>
+</p:sld>
+</file>
+
+<file path=ppt/slides/slide13.xml><?xml version="1.0" encoding="utf-8"?>
+<p:sld xmlns:a="http://schemas.openxmlformats.org/drawingml/2006/main" xmlns:p="http://schemas.openxmlformats.org/presentationml/2006/main" xmlns:r="http://schemas.openxmlformats.org/officeDocument/2006/relationships">
+  <p:cSld>
+    <p:spTree>
+      <p:nvGrpSpPr>
+        <p:cNvPr id="1" name=""/>
+        <p:cNvGrpSpPr/>
+        <p:nvPr/>
+      </p:nvGrpSpPr>
+      <p:grpSpPr/>
+      <p:pic>
+        <p:nvPicPr>
+          <p:cNvPr id="2" name="Picture 1" descr="image.jpg"/>
           <p:cNvPicPr>
             <a:picLocks noChangeAspect="1"/>
           </p:cNvPicPr>
@@ -3269,7 +3312,7 @@
       <p:grpSpPr/>
       <p:pic>
         <p:nvPicPr>
-          <p:cNvPr id="2" name="Picture 1" descr="s02.jpg"/>
+          <p:cNvPr id="2" name="Picture 1" descr="image.jpg"/>
           <p:cNvPicPr>
             <a:picLocks noChangeAspect="1"/>
           </p:cNvPicPr>
@@ -3311,7 +3354,7 @@
       <p:grpSpPr/>
       <p:pic>
         <p:nvPicPr>
-          <p:cNvPr id="2" name="Picture 1" descr="s03.jpg"/>
+          <p:cNvPr id="2" name="Picture 1" descr="image.jpg"/>
           <p:cNvPicPr>
             <a:picLocks noChangeAspect="1"/>
           </p:cNvPicPr>
@@ -3353,7 +3396,7 @@
       <p:grpSpPr/>
       <p:pic>
         <p:nvPicPr>
-          <p:cNvPr id="2" name="Picture 1" descr="s04.jpg"/>
+          <p:cNvPr id="2" name="Picture 1" descr="image.jpg"/>
           <p:cNvPicPr>
             <a:picLocks noChangeAspect="1"/>
           </p:cNvPicPr>
@@ -3395,7 +3438,7 @@
       <p:grpSpPr/>
       <p:pic>
         <p:nvPicPr>
-          <p:cNvPr id="2" name="Picture 1" descr="s05.jpg"/>
+          <p:cNvPr id="2" name="Picture 1" descr="image.jpg"/>
           <p:cNvPicPr>
             <a:picLocks noChangeAspect="1"/>
           </p:cNvPicPr>
@@ -3437,7 +3480,7 @@
       <p:grpSpPr/>
       <p:pic>
         <p:nvPicPr>
-          <p:cNvPr id="2" name="Picture 1" descr="s06.jpg"/>
+          <p:cNvPr id="2" name="Picture 1" descr="image.jpg"/>
           <p:cNvPicPr>
             <a:picLocks noChangeAspect="1"/>
           </p:cNvPicPr>
@@ -3479,7 +3522,7 @@
       <p:grpSpPr/>
       <p:pic>
         <p:nvPicPr>
-          <p:cNvPr id="2" name="Picture 1" descr="s07.jpg"/>
+          <p:cNvPr id="2" name="Picture 1" descr="image.jpg"/>
           <p:cNvPicPr>
             <a:picLocks noChangeAspect="1"/>
           </p:cNvPicPr>
@@ -3521,7 +3564,7 @@
       <p:grpSpPr/>
       <p:pic>
         <p:nvPicPr>
-          <p:cNvPr id="2" name="Picture 1" descr="s08.jpg"/>
+          <p:cNvPr id="2" name="Picture 1" descr="image.jpg"/>
           <p:cNvPicPr>
             <a:picLocks noChangeAspect="1"/>
           </p:cNvPicPr>
@@ -3563,7 +3606,7 @@
       <p:grpSpPr/>
       <p:pic>
         <p:nvPicPr>
-          <p:cNvPr id="2" name="Picture 1" descr="s09.jpg"/>
+          <p:cNvPr id="2" name="Picture 1" descr="image.jpg"/>
           <p:cNvPicPr>
             <a:picLocks noChangeAspect="1"/>
           </p:cNvPicPr>

</xml_diff>

<commit_message>
content: add problem/solution statement, decision matrix, flowchart, pseudocode & references slides; real GitHub links
</commit_message>
<xml_diff>
--- a/docs/Navigation-Guidance-Capstone-light.pptx
+++ b/docs/Navigation-Guidance-Capstone-light.pptx
@@ -18,6 +18,11 @@
     <p:sldId id="266" r:id="rId17"/>
     <p:sldId id="267" r:id="rId18"/>
     <p:sldId id="268" r:id="rId19"/>
+    <p:sldId id="269" r:id="rId20"/>
+    <p:sldId id="270" r:id="rId21"/>
+    <p:sldId id="271" r:id="rId22"/>
+    <p:sldId id="272" r:id="rId23"/>
+    <p:sldId id="273" r:id="rId24"/>
   </p:sldIdLst>
   <p:sldSz cx="12191695" cy="6858000" type="screen4x3"/>
   <p:notesSz cx="6858000" cy="9144000"/>
@@ -3259,6 +3264,216 @@
 </file>
 
 <file path=ppt/slides/slide13.xml><?xml version="1.0" encoding="utf-8"?>
+<p:sld xmlns:a="http://schemas.openxmlformats.org/drawingml/2006/main" xmlns:p="http://schemas.openxmlformats.org/presentationml/2006/main" xmlns:r="http://schemas.openxmlformats.org/officeDocument/2006/relationships">
+  <p:cSld>
+    <p:spTree>
+      <p:nvGrpSpPr>
+        <p:cNvPr id="1" name=""/>
+        <p:cNvGrpSpPr/>
+        <p:nvPr/>
+      </p:nvGrpSpPr>
+      <p:grpSpPr/>
+      <p:pic>
+        <p:nvPicPr>
+          <p:cNvPr id="2" name="Picture 1" descr="image.jpg"/>
+          <p:cNvPicPr>
+            <a:picLocks noChangeAspect="1"/>
+          </p:cNvPicPr>
+          <p:nvPr/>
+        </p:nvPicPr>
+        <p:blipFill>
+          <a:blip r:embed="rId2"/>
+          <a:stretch>
+            <a:fillRect/>
+          </a:stretch>
+        </p:blipFill>
+        <p:spPr>
+          <a:xfrm>
+            <a:off x="0" y="0"/>
+            <a:ext cx="12191695" cy="6858000"/>
+          </a:xfrm>
+          <a:prstGeom prst="rect">
+            <a:avLst/>
+          </a:prstGeom>
+        </p:spPr>
+      </p:pic>
+    </p:spTree>
+  </p:cSld>
+  <p:clrMapOvr>
+    <a:masterClrMapping/>
+  </p:clrMapOvr>
+</p:sld>
+</file>
+
+<file path=ppt/slides/slide14.xml><?xml version="1.0" encoding="utf-8"?>
+<p:sld xmlns:a="http://schemas.openxmlformats.org/drawingml/2006/main" xmlns:p="http://schemas.openxmlformats.org/presentationml/2006/main" xmlns:r="http://schemas.openxmlformats.org/officeDocument/2006/relationships">
+  <p:cSld>
+    <p:spTree>
+      <p:nvGrpSpPr>
+        <p:cNvPr id="1" name=""/>
+        <p:cNvGrpSpPr/>
+        <p:nvPr/>
+      </p:nvGrpSpPr>
+      <p:grpSpPr/>
+      <p:pic>
+        <p:nvPicPr>
+          <p:cNvPr id="2" name="Picture 1" descr="image.jpg"/>
+          <p:cNvPicPr>
+            <a:picLocks noChangeAspect="1"/>
+          </p:cNvPicPr>
+          <p:nvPr/>
+        </p:nvPicPr>
+        <p:blipFill>
+          <a:blip r:embed="rId2"/>
+          <a:stretch>
+            <a:fillRect/>
+          </a:stretch>
+        </p:blipFill>
+        <p:spPr>
+          <a:xfrm>
+            <a:off x="0" y="0"/>
+            <a:ext cx="12191695" cy="6858000"/>
+          </a:xfrm>
+          <a:prstGeom prst="rect">
+            <a:avLst/>
+          </a:prstGeom>
+        </p:spPr>
+      </p:pic>
+    </p:spTree>
+  </p:cSld>
+  <p:clrMapOvr>
+    <a:masterClrMapping/>
+  </p:clrMapOvr>
+</p:sld>
+</file>
+
+<file path=ppt/slides/slide15.xml><?xml version="1.0" encoding="utf-8"?>
+<p:sld xmlns:a="http://schemas.openxmlformats.org/drawingml/2006/main" xmlns:p="http://schemas.openxmlformats.org/presentationml/2006/main" xmlns:r="http://schemas.openxmlformats.org/officeDocument/2006/relationships">
+  <p:cSld>
+    <p:spTree>
+      <p:nvGrpSpPr>
+        <p:cNvPr id="1" name=""/>
+        <p:cNvGrpSpPr/>
+        <p:nvPr/>
+      </p:nvGrpSpPr>
+      <p:grpSpPr/>
+      <p:pic>
+        <p:nvPicPr>
+          <p:cNvPr id="2" name="Picture 1" descr="image.jpg"/>
+          <p:cNvPicPr>
+            <a:picLocks noChangeAspect="1"/>
+          </p:cNvPicPr>
+          <p:nvPr/>
+        </p:nvPicPr>
+        <p:blipFill>
+          <a:blip r:embed="rId2"/>
+          <a:stretch>
+            <a:fillRect/>
+          </a:stretch>
+        </p:blipFill>
+        <p:spPr>
+          <a:xfrm>
+            <a:off x="0" y="0"/>
+            <a:ext cx="12191695" cy="6858000"/>
+          </a:xfrm>
+          <a:prstGeom prst="rect">
+            <a:avLst/>
+          </a:prstGeom>
+        </p:spPr>
+      </p:pic>
+    </p:spTree>
+  </p:cSld>
+  <p:clrMapOvr>
+    <a:masterClrMapping/>
+  </p:clrMapOvr>
+</p:sld>
+</file>
+
+<file path=ppt/slides/slide16.xml><?xml version="1.0" encoding="utf-8"?>
+<p:sld xmlns:a="http://schemas.openxmlformats.org/drawingml/2006/main" xmlns:p="http://schemas.openxmlformats.org/presentationml/2006/main" xmlns:r="http://schemas.openxmlformats.org/officeDocument/2006/relationships">
+  <p:cSld>
+    <p:spTree>
+      <p:nvGrpSpPr>
+        <p:cNvPr id="1" name=""/>
+        <p:cNvGrpSpPr/>
+        <p:nvPr/>
+      </p:nvGrpSpPr>
+      <p:grpSpPr/>
+      <p:pic>
+        <p:nvPicPr>
+          <p:cNvPr id="2" name="Picture 1" descr="image.jpg"/>
+          <p:cNvPicPr>
+            <a:picLocks noChangeAspect="1"/>
+          </p:cNvPicPr>
+          <p:nvPr/>
+        </p:nvPicPr>
+        <p:blipFill>
+          <a:blip r:embed="rId2"/>
+          <a:stretch>
+            <a:fillRect/>
+          </a:stretch>
+        </p:blipFill>
+        <p:spPr>
+          <a:xfrm>
+            <a:off x="0" y="0"/>
+            <a:ext cx="12191695" cy="6858000"/>
+          </a:xfrm>
+          <a:prstGeom prst="rect">
+            <a:avLst/>
+          </a:prstGeom>
+        </p:spPr>
+      </p:pic>
+    </p:spTree>
+  </p:cSld>
+  <p:clrMapOvr>
+    <a:masterClrMapping/>
+  </p:clrMapOvr>
+</p:sld>
+</file>
+
+<file path=ppt/slides/slide17.xml><?xml version="1.0" encoding="utf-8"?>
+<p:sld xmlns:a="http://schemas.openxmlformats.org/drawingml/2006/main" xmlns:p="http://schemas.openxmlformats.org/presentationml/2006/main" xmlns:r="http://schemas.openxmlformats.org/officeDocument/2006/relationships">
+  <p:cSld>
+    <p:spTree>
+      <p:nvGrpSpPr>
+        <p:cNvPr id="1" name=""/>
+        <p:cNvGrpSpPr/>
+        <p:nvPr/>
+      </p:nvGrpSpPr>
+      <p:grpSpPr/>
+      <p:pic>
+        <p:nvPicPr>
+          <p:cNvPr id="2" name="Picture 1" descr="image.jpg"/>
+          <p:cNvPicPr>
+            <a:picLocks noChangeAspect="1"/>
+          </p:cNvPicPr>
+          <p:nvPr/>
+        </p:nvPicPr>
+        <p:blipFill>
+          <a:blip r:embed="rId2"/>
+          <a:stretch>
+            <a:fillRect/>
+          </a:stretch>
+        </p:blipFill>
+        <p:spPr>
+          <a:xfrm>
+            <a:off x="0" y="0"/>
+            <a:ext cx="12191695" cy="6858000"/>
+          </a:xfrm>
+          <a:prstGeom prst="rect">
+            <a:avLst/>
+          </a:prstGeom>
+        </p:spPr>
+      </p:pic>
+    </p:spTree>
+  </p:cSld>
+  <p:clrMapOvr>
+    <a:masterClrMapping/>
+  </p:clrMapOvr>
+</p:sld>
+</file>
+
+<file path=ppt/slides/slide18.xml><?xml version="1.0" encoding="utf-8"?>
 <p:sld xmlns:a="http://schemas.openxmlformats.org/drawingml/2006/main" xmlns:p="http://schemas.openxmlformats.org/presentationml/2006/main" xmlns:r="http://schemas.openxmlformats.org/officeDocument/2006/relationships">
   <p:cSld>
     <p:spTree>

</xml_diff>